<commit_message>
Add USD-normalized revenue comparison slide (4 LLM startups)
Side-by-side 2025 revenue in US$M (converted at RMB7.2/US$) for Zhipu /
MiniMax / Kimi / StepFun, with estimate flags and a note on
non-comparable revenue recognition across To-C vs To-B models.

https://claude.ai/code/session_01R8rvQ5ouXhqXBdN5LcqLMU
</commit_message>
<xml_diff>
--- a/MiniMax_前瞻_DCF_竞争格局.pptx
+++ b/MiniMax_前瞻_DCF_竞争格局.pptx
@@ -23,6 +23,7 @@
     <p:sldId id="271" r:id="rId22"/>
     <p:sldId id="272" r:id="rId23"/>
     <p:sldId id="273" r:id="rId24"/>
+    <p:sldId id="274" r:id="rId25"/>
   </p:sldIdLst>
   <p:sldSz cx="12191695" cy="6858000" type="screen4x3"/>
   <p:notesSz cx="6858000" cy="9144000"/>
@@ -773,6 +774,154 @@
 </c:chartSpace>
 </file>
 
+<file path=ppt/charts/chart4.xml><?xml version="1.0" encoding="utf-8"?>
+<c:chartSpace xmlns:c="http://schemas.openxmlformats.org/drawingml/2006/chart" xmlns:a="http://schemas.openxmlformats.org/drawingml/2006/main" xmlns:r="http://schemas.openxmlformats.org/officeDocument/2006/relationships">
+  <c:date1904 val="0"/>
+  <c:chart>
+    <c:autoTitleDeleted val="0"/>
+    <c:plotArea>
+      <c:barChart>
+        <c:barDir val="col"/>
+        <c:grouping val="clustered"/>
+        <c:ser>
+          <c:idx val="0"/>
+          <c:order val="0"/>
+          <c:tx>
+            <c:strRef>
+              <c:f>Sheet1!$B$1</c:f>
+              <c:strCache>
+                <c:ptCount val="1"/>
+                <c:pt idx="0">
+                  <c:v>2025 营收 (US$M)</c:v>
+                </c:pt>
+              </c:strCache>
+            </c:strRef>
+          </c:tx>
+          <c:spPr>
+            <a:solidFill>
+              <a:srgbClr val="5D6D9E"/>
+            </a:solidFill>
+          </c:spPr>
+          <c:dPt>
+            <c:idx val="1"/>
+            <c:spPr>
+              <a:solidFill>
+                <a:srgbClr val="2E86C1"/>
+              </a:solidFill>
+            </c:spPr>
+          </c:dPt>
+          <c:cat>
+            <c:strRef>
+              <c:f>Sheet1!$A$2:$A$5</c:f>
+              <c:strCache>
+                <c:ptCount val="4"/>
+                <c:pt idx="0">
+                  <c:v>智谱 (25E)</c:v>
+                </c:pt>
+                <c:pt idx="1">
+                  <c:v>MiniMax (25A)</c:v>
+                </c:pt>
+                <c:pt idx="2">
+                  <c:v>Kimi (25)</c:v>
+                </c:pt>
+                <c:pt idx="3">
+                  <c:v>阶跃 (25)</c:v>
+                </c:pt>
+              </c:strCache>
+            </c:strRef>
+          </c:cat>
+          <c:val>
+            <c:numRef>
+              <c:f>Sheet1!$B$2:$B$5</c:f>
+              <c:numCache>
+                <c:formatCode>General</c:formatCode>
+                <c:ptCount val="4"/>
+                <c:pt idx="0">
+                  <c:v>97</c:v>
+                </c:pt>
+                <c:pt idx="1">
+                  <c:v>79</c:v>
+                </c:pt>
+                <c:pt idx="2">
+                  <c:v>69</c:v>
+                </c:pt>
+                <c:pt idx="3">
+                  <c:v>69</c:v>
+                </c:pt>
+              </c:numCache>
+            </c:numRef>
+          </c:val>
+        </c:ser>
+        <c:dLbls>
+          <c:numFmt formatCode="0" sourceLinked="0"/>
+          <c:txPr>
+            <a:bodyPr/>
+            <a:lstStyle/>
+            <a:p>
+              <a:pPr>
+                <a:defRPr sz="1200" b="1"/>
+              </a:pPr>
+            </a:p>
+          </c:txPr>
+          <c:showLegendKey val="0"/>
+          <c:showVal val="1"/>
+          <c:showCatName val="0"/>
+          <c:showSerName val="0"/>
+          <c:showPercent val="0"/>
+          <c:showBubbleSize val="0"/>
+          <c:showLeaderLines val="1"/>
+        </c:dLbls>
+        <c:axId val="-2068027336"/>
+        <c:axId val="-2113994440"/>
+      </c:barChart>
+      <c:catAx>
+        <c:axId val="-2068027336"/>
+        <c:scaling>
+          <c:orientation val="minMax"/>
+        </c:scaling>
+        <c:delete val="0"/>
+        <c:axPos val="b"/>
+        <c:majorTickMark val="out"/>
+        <c:minorTickMark val="none"/>
+        <c:tickLblPos val="nextTo"/>
+        <c:crossAx val="-2113994440"/>
+        <c:crosses val="autoZero"/>
+        <c:auto val="1"/>
+        <c:lblAlgn val="ctr"/>
+        <c:lblOffset val="100"/>
+        <c:noMultiLvlLbl val="0"/>
+      </c:catAx>
+      <c:valAx>
+        <c:axId val="-2113994440"/>
+        <c:scaling/>
+        <c:delete val="0"/>
+        <c:axPos val="l"/>
+        <c:majorGridlines/>
+        <c:majorTickMark val="out"/>
+        <c:minorTickMark val="none"/>
+        <c:tickLblPos val="nextTo"/>
+        <c:crossAx val="-2068027336"/>
+        <c:crosses val="autoZero"/>
+      </c:valAx>
+    </c:plotArea>
+    <c:dispBlanksAs val="gap"/>
+  </c:chart>
+  <c:txPr>
+    <a:bodyPr/>
+    <a:lstStyle/>
+    <a:p>
+      <a:pPr>
+        <a:defRPr sz="1800"/>
+      </a:pPr>
+      <a:endParaRPr lang="en-US"/>
+    </a:p>
+  </c:txPr>
+  <c:externalData r:id="rId1">
+    <c:autoUpdate val="0"/>
+  </c:externalData>
+</c:chartSpace>
+</file>
+
 <file path=ppt/slideLayouts/slideLayout1.xml><?xml version="1.0" encoding="utf-8"?>
 <p:sldLayout xmlns:a="http://schemas.openxmlformats.org/drawingml/2006/main" xmlns:r="http://schemas.openxmlformats.org/officeDocument/2006/relationships" xmlns:p="http://schemas.openxmlformats.org/presentationml/2006/main" type="title" preserve="1">
   <p:cSld name="Title Slide">
@@ -7315,14 +7464,78 @@
                 </a:solidFill>
                 <a:latin typeface="Microsoft YaHei"/>
               </a:rPr>
-              <a:t>两条 IPO 路线对照：MiniMax 的 To C 出海 vs 智谱的 To B 政企</a:t>
+              <a:t>【竞争格局】营收规模对齐（统一折算 US$M）：四家体量接近，差距在增速与估值</a:t>
+            </a:r>
+          </a:p>
+          <a:p>
+            <a:pPr algn="l"/>
+            <a:r>
+              <a:rPr sz="1350" b="0">
+                <a:solidFill>
+                  <a:srgbClr val="6B707B"/>
+                </a:solidFill>
+                <a:latin typeface="Microsoft YaHei"/>
+              </a:rPr>
+              <a:t>2025 营收，按 ¥7.2/US$ 折算</a:t>
+            </a:r>
+          </a:p>
+        </p:txBody>
+      </p:sp>
+      <p:sp>
+        <p:nvSpPr>
+          <p:cNvPr id="4" name="Rectangle 3"/>
+          <p:cNvSpPr/>
+          <p:nvPr/>
+        </p:nvSpPr>
+        <p:spPr>
+          <a:xfrm>
+            <a:off x="10104120" y="274320"/>
+            <a:ext cx="1783080" cy="384048"/>
+          </a:xfrm>
+          <a:prstGeom prst="rect">
+            <a:avLst/>
+          </a:prstGeom>
+          <a:solidFill>
+            <a:srgbClr val="5D6D9E"/>
+          </a:solidFill>
+          <a:ln>
+            <a:noFill/>
+          </a:ln>
+        </p:spPr>
+        <p:style>
+          <a:lnRef idx="1">
+            <a:schemeClr val="accent1"/>
+          </a:lnRef>
+          <a:fillRef idx="3">
+            <a:schemeClr val="accent1"/>
+          </a:fillRef>
+          <a:effectRef idx="2">
+            <a:schemeClr val="accent1"/>
+          </a:effectRef>
+          <a:fontRef idx="minor">
+            <a:schemeClr val="lt1"/>
+          </a:fontRef>
+        </p:style>
+        <p:txBody>
+          <a:bodyPr rtlCol="0" anchor="ctr"/>
+          <a:lstStyle/>
+          <a:p>
+            <a:pPr algn="ctr"/>
+            <a:r>
+              <a:rPr sz="1200" b="1">
+                <a:solidFill>
+                  <a:srgbClr val="FFFFFF"/>
+                </a:solidFill>
+                <a:latin typeface="Microsoft YaHei"/>
+              </a:rPr>
+              <a:t>③ 竞争格局</a:t>
             </a:r>
           </a:p>
         </p:txBody>
       </p:sp>
       <p:graphicFrame>
         <p:nvGraphicFramePr>
-          <p:cNvPr id="4" name="Table 3"/>
+          <p:cNvPr id="5" name="Chart 4"/>
           <p:cNvGraphicFramePr>
             <a:graphicFrameLocks noGrp="1"/>
           </p:cNvGraphicFramePr>
@@ -7330,665 +7543,120 @@
         </p:nvGraphicFramePr>
         <p:xfrm>
           <a:off x="457200" y="1691640"/>
-          <a:ext cx="11247120" cy="4206240"/>
+          <a:ext cx="6035040" cy="4206240"/>
         </p:xfrm>
         <a:graphic>
-          <a:graphicData uri="http://schemas.openxmlformats.org/drawingml/2006/table">
-            <a:tbl>
-              <a:tblPr firstRow="1" bandRow="1">
-                <a:tableStyleId>{5C22544A-7EE6-4342-B048-85BDC9FD1C3A}</a:tableStyleId>
-              </a:tblPr>
-              <a:tblGrid>
-                <a:gridCol w="2103120"/>
-                <a:gridCol w="4572000"/>
-                <a:gridCol w="4572000"/>
-              </a:tblGrid>
-              <a:tr h="467360">
-                <a:tc>
-                  <a:txBody>
-                    <a:bodyPr wrap="square"/>
-                    <a:lstStyle/>
-                    <a:p>
-                      <a:pPr algn="l"/>
-                      <a:r>
-                        <a:rPr sz="1250" b="1">
-                          <a:solidFill>
-                            <a:srgbClr val="FFFFFF"/>
-                          </a:solidFill>
-                          <a:latin typeface="Microsoft YaHei"/>
-                        </a:rPr>
-                        <a:t>维度</a:t>
-                      </a:r>
-                    </a:p>
-                  </a:txBody>
-                  <a:tcPr marL="54864" marR="54864" marT="18288" marB="18288" anchor="ctr">
-                    <a:solidFill>
-                      <a:srgbClr val="16213E"/>
-                    </a:solidFill>
-                  </a:tcPr>
-                </a:tc>
-                <a:tc>
-                  <a:txBody>
-                    <a:bodyPr wrap="square"/>
-                    <a:lstStyle/>
-                    <a:p>
-                      <a:pPr algn="l"/>
-                      <a:r>
-                        <a:rPr sz="1250" b="1">
-                          <a:solidFill>
-                            <a:srgbClr val="FFFFFF"/>
-                          </a:solidFill>
-                          <a:latin typeface="Microsoft YaHei"/>
-                        </a:rPr>
-                        <a:t>MiniMax (00100.HK)</a:t>
-                      </a:r>
-                    </a:p>
-                  </a:txBody>
-                  <a:tcPr marL="54864" marR="54864" marT="18288" marB="18288" anchor="ctr">
-                    <a:solidFill>
-                      <a:srgbClr val="16213E"/>
-                    </a:solidFill>
-                  </a:tcPr>
-                </a:tc>
-                <a:tc>
-                  <a:txBody>
-                    <a:bodyPr wrap="square"/>
-                    <a:lstStyle/>
-                    <a:p>
-                      <a:pPr algn="l"/>
-                      <a:r>
-                        <a:rPr sz="1250" b="1">
-                          <a:solidFill>
-                            <a:srgbClr val="FFFFFF"/>
-                          </a:solidFill>
-                          <a:latin typeface="Microsoft YaHei"/>
-                        </a:rPr>
-                        <a:t>智谱 AI</a:t>
-                      </a:r>
-                    </a:p>
-                  </a:txBody>
-                  <a:tcPr marL="54864" marR="54864" marT="18288" marB="18288" anchor="ctr">
-                    <a:solidFill>
-                      <a:srgbClr val="16213E"/>
-                    </a:solidFill>
-                  </a:tcPr>
-                </a:tc>
-              </a:tr>
-              <a:tr h="467360">
-                <a:tc>
-                  <a:txBody>
-                    <a:bodyPr wrap="square"/>
-                    <a:lstStyle/>
-                    <a:p>
-                      <a:pPr algn="l"/>
-                      <a:r>
-                        <a:rPr sz="1250" b="0">
-                          <a:solidFill>
-                            <a:srgbClr val="16213E"/>
-                          </a:solidFill>
-                          <a:latin typeface="Microsoft YaHei"/>
-                        </a:rPr>
-                        <a:t>客户结构</a:t>
-                      </a:r>
-                    </a:p>
-                  </a:txBody>
-                  <a:tcPr marL="54864" marR="54864" marT="18288" marB="18288" anchor="ctr">
-                    <a:solidFill>
-                      <a:srgbClr val="FFFFFF"/>
-                    </a:solidFill>
-                  </a:tcPr>
-                </a:tc>
-                <a:tc>
-                  <a:txBody>
-                    <a:bodyPr wrap="square"/>
-                    <a:lstStyle/>
-                    <a:p>
-                      <a:pPr algn="l"/>
-                      <a:r>
-                        <a:rPr sz="1250" b="0">
-                          <a:solidFill>
-                            <a:srgbClr val="16213E"/>
-                          </a:solidFill>
-                          <a:latin typeface="Microsoft YaHei"/>
-                        </a:rPr>
-                        <a:t>To C 为主 (~70% 消费级)</a:t>
-                      </a:r>
-                    </a:p>
-                  </a:txBody>
-                  <a:tcPr marL="54864" marR="54864" marT="18288" marB="18288" anchor="ctr">
-                    <a:solidFill>
-                      <a:srgbClr val="FFFFFF"/>
-                    </a:solidFill>
-                  </a:tcPr>
-                </a:tc>
-                <a:tc>
-                  <a:txBody>
-                    <a:bodyPr wrap="square"/>
-                    <a:lstStyle/>
-                    <a:p>
-                      <a:pPr algn="l"/>
-                      <a:r>
-                        <a:rPr sz="1250" b="0">
-                          <a:solidFill>
-                            <a:srgbClr val="16213E"/>
-                          </a:solidFill>
-                          <a:latin typeface="Microsoft YaHei"/>
-                        </a:rPr>
-                        <a:t>To B 为主 (84% 本地化部署)</a:t>
-                      </a:r>
-                    </a:p>
-                  </a:txBody>
-                  <a:tcPr marL="54864" marR="54864" marT="18288" marB="18288" anchor="ctr">
-                    <a:solidFill>
-                      <a:srgbClr val="FFFFFF"/>
-                    </a:solidFill>
-                  </a:tcPr>
-                </a:tc>
-              </a:tr>
-              <a:tr h="467360">
-                <a:tc>
-                  <a:txBody>
-                    <a:bodyPr wrap="square"/>
-                    <a:lstStyle/>
-                    <a:p>
-                      <a:pPr algn="l"/>
-                      <a:r>
-                        <a:rPr sz="1250" b="0">
-                          <a:solidFill>
-                            <a:srgbClr val="16213E"/>
-                          </a:solidFill>
-                          <a:latin typeface="Microsoft YaHei"/>
-                        </a:rPr>
-                        <a:t>市场重心</a:t>
-                      </a:r>
-                    </a:p>
-                  </a:txBody>
-                  <a:tcPr marL="54864" marR="54864" marT="18288" marB="18288" anchor="ctr">
-                    <a:solidFill>
-                      <a:srgbClr val="E9EBEF"/>
-                    </a:solidFill>
-                  </a:tcPr>
-                </a:tc>
-                <a:tc>
-                  <a:txBody>
-                    <a:bodyPr wrap="square"/>
-                    <a:lstStyle/>
-                    <a:p>
-                      <a:pPr algn="l"/>
-                      <a:r>
-                        <a:rPr sz="1250" b="0">
-                          <a:solidFill>
-                            <a:srgbClr val="16213E"/>
-                          </a:solidFill>
-                          <a:latin typeface="Microsoft YaHei"/>
-                        </a:rPr>
-                        <a:t>海外优先 (73% 海外收入)</a:t>
-                      </a:r>
-                    </a:p>
-                  </a:txBody>
-                  <a:tcPr marL="54864" marR="54864" marT="18288" marB="18288" anchor="ctr">
-                    <a:solidFill>
-                      <a:srgbClr val="E9EBEF"/>
-                    </a:solidFill>
-                  </a:tcPr>
-                </a:tc>
-                <a:tc>
-                  <a:txBody>
-                    <a:bodyPr wrap="square"/>
-                    <a:lstStyle/>
-                    <a:p>
-                      <a:pPr algn="l"/>
-                      <a:r>
-                        <a:rPr sz="1250" b="0">
-                          <a:solidFill>
-                            <a:srgbClr val="16213E"/>
-                          </a:solidFill>
-                          <a:latin typeface="Microsoft YaHei"/>
-                        </a:rPr>
-                        <a:t>国内政企 / 国资体系</a:t>
-                      </a:r>
-                    </a:p>
-                  </a:txBody>
-                  <a:tcPr marL="54864" marR="54864" marT="18288" marB="18288" anchor="ctr">
-                    <a:solidFill>
-                      <a:srgbClr val="E9EBEF"/>
-                    </a:solidFill>
-                  </a:tcPr>
-                </a:tc>
-              </a:tr>
-              <a:tr h="467360">
-                <a:tc>
-                  <a:txBody>
-                    <a:bodyPr wrap="square"/>
-                    <a:lstStyle/>
-                    <a:p>
-                      <a:pPr algn="l"/>
-                      <a:r>
-                        <a:rPr sz="1250" b="0">
-                          <a:solidFill>
-                            <a:srgbClr val="16213E"/>
-                          </a:solidFill>
-                          <a:latin typeface="Microsoft YaHei"/>
-                        </a:rPr>
-                        <a:t>营收 (2024)</a:t>
-                      </a:r>
-                    </a:p>
-                  </a:txBody>
-                  <a:tcPr marL="54864" marR="54864" marT="18288" marB="18288" anchor="ctr">
-                    <a:solidFill>
-                      <a:srgbClr val="FFFFFF"/>
-                    </a:solidFill>
-                  </a:tcPr>
-                </a:tc>
-                <a:tc>
-                  <a:txBody>
-                    <a:bodyPr wrap="square"/>
-                    <a:lstStyle/>
-                    <a:p>
-                      <a:pPr algn="l"/>
-                      <a:r>
-                        <a:rPr sz="1250" b="0">
-                          <a:solidFill>
-                            <a:srgbClr val="16213E"/>
-                          </a:solidFill>
-                          <a:latin typeface="Microsoft YaHei"/>
-                        </a:rPr>
-                        <a:t>$30.5M (~¥2.2亿)</a:t>
-                      </a:r>
-                    </a:p>
-                  </a:txBody>
-                  <a:tcPr marL="54864" marR="54864" marT="18288" marB="18288" anchor="ctr">
-                    <a:solidFill>
-                      <a:srgbClr val="FFFFFF"/>
-                    </a:solidFill>
-                  </a:tcPr>
-                </a:tc>
-                <a:tc>
-                  <a:txBody>
-                    <a:bodyPr wrap="square"/>
-                    <a:lstStyle/>
-                    <a:p>
-                      <a:pPr algn="l"/>
-                      <a:r>
-                        <a:rPr sz="1250" b="0">
-                          <a:solidFill>
-                            <a:srgbClr val="16213E"/>
-                          </a:solidFill>
-                          <a:latin typeface="Microsoft YaHei"/>
-                        </a:rPr>
-                        <a:t>¥3.12 亿</a:t>
-                      </a:r>
-                    </a:p>
-                  </a:txBody>
-                  <a:tcPr marL="54864" marR="54864" marT="18288" marB="18288" anchor="ctr">
-                    <a:solidFill>
-                      <a:srgbClr val="FFFFFF"/>
-                    </a:solidFill>
-                  </a:tcPr>
-                </a:tc>
-              </a:tr>
-              <a:tr h="467360">
-                <a:tc>
-                  <a:txBody>
-                    <a:bodyPr wrap="square"/>
-                    <a:lstStyle/>
-                    <a:p>
-                      <a:pPr algn="l"/>
-                      <a:r>
-                        <a:rPr sz="1250" b="0">
-                          <a:solidFill>
-                            <a:srgbClr val="16213E"/>
-                          </a:solidFill>
-                          <a:latin typeface="Microsoft YaHei"/>
-                        </a:rPr>
-                        <a:t>营收增速</a:t>
-                      </a:r>
-                    </a:p>
-                  </a:txBody>
-                  <a:tcPr marL="54864" marR="54864" marT="18288" marB="18288" anchor="ctr">
-                    <a:solidFill>
-                      <a:srgbClr val="E9EBEF"/>
-                    </a:solidFill>
-                  </a:tcPr>
-                </a:tc>
-                <a:tc>
-                  <a:txBody>
-                    <a:bodyPr wrap="square"/>
-                    <a:lstStyle/>
-                    <a:p>
-                      <a:pPr algn="l"/>
-                      <a:r>
-                        <a:rPr sz="1250" b="0">
-                          <a:solidFill>
-                            <a:srgbClr val="16213E"/>
-                          </a:solidFill>
-                          <a:latin typeface="Microsoft YaHei"/>
-                        </a:rPr>
-                        <a:t>2025 +159%</a:t>
-                      </a:r>
-                    </a:p>
-                  </a:txBody>
-                  <a:tcPr marL="54864" marR="54864" marT="18288" marB="18288" anchor="ctr">
-                    <a:solidFill>
-                      <a:srgbClr val="E9EBEF"/>
-                    </a:solidFill>
-                  </a:tcPr>
-                </a:tc>
-                <a:tc>
-                  <a:txBody>
-                    <a:bodyPr wrap="square"/>
-                    <a:lstStyle/>
-                    <a:p>
-                      <a:pPr algn="l"/>
-                      <a:r>
-                        <a:rPr sz="1250" b="0">
-                          <a:solidFill>
-                            <a:srgbClr val="16213E"/>
-                          </a:solidFill>
-                          <a:latin typeface="Microsoft YaHei"/>
-                        </a:rPr>
-                        <a:t>三年 CAGR ~130%</a:t>
-                      </a:r>
-                    </a:p>
-                  </a:txBody>
-                  <a:tcPr marL="54864" marR="54864" marT="18288" marB="18288" anchor="ctr">
-                    <a:solidFill>
-                      <a:srgbClr val="E9EBEF"/>
-                    </a:solidFill>
-                  </a:tcPr>
-                </a:tc>
-              </a:tr>
-              <a:tr h="467360">
-                <a:tc>
-                  <a:txBody>
-                    <a:bodyPr wrap="square"/>
-                    <a:lstStyle/>
-                    <a:p>
-                      <a:pPr algn="l"/>
-                      <a:r>
-                        <a:rPr sz="1250" b="0">
-                          <a:solidFill>
-                            <a:srgbClr val="16213E"/>
-                          </a:solidFill>
-                          <a:latin typeface="Microsoft YaHei"/>
-                        </a:rPr>
-                        <a:t>估值</a:t>
-                      </a:r>
-                    </a:p>
-                  </a:txBody>
-                  <a:tcPr marL="54864" marR="54864" marT="18288" marB="18288" anchor="ctr">
-                    <a:solidFill>
-                      <a:srgbClr val="FFFFFF"/>
-                    </a:solidFill>
-                  </a:tcPr>
-                </a:tc>
-                <a:tc>
-                  <a:txBody>
-                    <a:bodyPr wrap="square"/>
-                    <a:lstStyle/>
-                    <a:p>
-                      <a:pPr algn="l"/>
-                      <a:r>
-                        <a:rPr sz="1250" b="0">
-                          <a:solidFill>
-                            <a:srgbClr val="16213E"/>
-                          </a:solidFill>
-                          <a:latin typeface="Microsoft YaHei"/>
-                        </a:rPr>
-                        <a:t>≈ US$5.9B (上市市值)</a:t>
-                      </a:r>
-                    </a:p>
-                  </a:txBody>
-                  <a:tcPr marL="54864" marR="54864" marT="18288" marB="18288" anchor="ctr">
-                    <a:solidFill>
-                      <a:srgbClr val="FFFFFF"/>
-                    </a:solidFill>
-                  </a:tcPr>
-                </a:tc>
-                <a:tc>
-                  <a:txBody>
-                    <a:bodyPr wrap="square"/>
-                    <a:lstStyle/>
-                    <a:p>
-                      <a:pPr algn="l"/>
-                      <a:r>
-                        <a:rPr sz="1250" b="0">
-                          <a:solidFill>
-                            <a:srgbClr val="16213E"/>
-                          </a:solidFill>
-                          <a:latin typeface="Microsoft YaHei"/>
-                        </a:rPr>
-                        <a:t>≈ ¥244 亿 (~$3.4B)</a:t>
-                      </a:r>
-                    </a:p>
-                  </a:txBody>
-                  <a:tcPr marL="54864" marR="54864" marT="18288" marB="18288" anchor="ctr">
-                    <a:solidFill>
-                      <a:srgbClr val="FFFFFF"/>
-                    </a:solidFill>
-                  </a:tcPr>
-                </a:tc>
-              </a:tr>
-              <a:tr h="467360">
-                <a:tc>
-                  <a:txBody>
-                    <a:bodyPr wrap="square"/>
-                    <a:lstStyle/>
-                    <a:p>
-                      <a:pPr algn="l"/>
-                      <a:r>
-                        <a:rPr sz="1250" b="0">
-                          <a:solidFill>
-                            <a:srgbClr val="16213E"/>
-                          </a:solidFill>
-                          <a:latin typeface="Microsoft YaHei"/>
-                        </a:rPr>
-                        <a:t>上市进度</a:t>
-                      </a:r>
-                    </a:p>
-                  </a:txBody>
-                  <a:tcPr marL="54864" marR="54864" marT="18288" marB="18288" anchor="ctr">
-                    <a:solidFill>
-                      <a:srgbClr val="E9EBEF"/>
-                    </a:solidFill>
-                  </a:tcPr>
-                </a:tc>
-                <a:tc>
-                  <a:txBody>
-                    <a:bodyPr wrap="square"/>
-                    <a:lstStyle/>
-                    <a:p>
-                      <a:pPr algn="l"/>
-                      <a:r>
-                        <a:rPr sz="1250" b="0">
-                          <a:solidFill>
-                            <a:srgbClr val="16213E"/>
-                          </a:solidFill>
-                          <a:latin typeface="Microsoft YaHei"/>
-                        </a:rPr>
-                        <a:t>已上市 2026-01-09</a:t>
-                      </a:r>
-                    </a:p>
-                  </a:txBody>
-                  <a:tcPr marL="54864" marR="54864" marT="18288" marB="18288" anchor="ctr">
-                    <a:solidFill>
-                      <a:srgbClr val="E9EBEF"/>
-                    </a:solidFill>
-                  </a:tcPr>
-                </a:tc>
-                <a:tc>
-                  <a:txBody>
-                    <a:bodyPr wrap="square"/>
-                    <a:lstStyle/>
-                    <a:p>
-                      <a:pPr algn="l"/>
-                      <a:r>
-                        <a:rPr sz="1250" b="0">
-                          <a:solidFill>
-                            <a:srgbClr val="16213E"/>
-                          </a:solidFill>
-                          <a:latin typeface="Microsoft YaHei"/>
-                        </a:rPr>
-                        <a:t>通过聆讯，冲“第一股”</a:t>
-                      </a:r>
-                    </a:p>
-                  </a:txBody>
-                  <a:tcPr marL="54864" marR="54864" marT="18288" marB="18288" anchor="ctr">
-                    <a:solidFill>
-                      <a:srgbClr val="E9EBEF"/>
-                    </a:solidFill>
-                  </a:tcPr>
-                </a:tc>
-              </a:tr>
-              <a:tr h="467360">
-                <a:tc>
-                  <a:txBody>
-                    <a:bodyPr wrap="square"/>
-                    <a:lstStyle/>
-                    <a:p>
-                      <a:pPr algn="l"/>
-                      <a:r>
-                        <a:rPr sz="1250" b="0">
-                          <a:solidFill>
-                            <a:srgbClr val="16213E"/>
-                          </a:solidFill>
-                          <a:latin typeface="Microsoft YaHei"/>
-                        </a:rPr>
-                        <a:t>代表模型</a:t>
-                      </a:r>
-                    </a:p>
-                  </a:txBody>
-                  <a:tcPr marL="54864" marR="54864" marT="18288" marB="18288" anchor="ctr">
-                    <a:solidFill>
-                      <a:srgbClr val="FFFFFF"/>
-                    </a:solidFill>
-                  </a:tcPr>
-                </a:tc>
-                <a:tc>
-                  <a:txBody>
-                    <a:bodyPr wrap="square"/>
-                    <a:lstStyle/>
-                    <a:p>
-                      <a:pPr algn="l"/>
-                      <a:r>
-                        <a:rPr sz="1250" b="0">
-                          <a:solidFill>
-                            <a:srgbClr val="16213E"/>
-                          </a:solidFill>
-                          <a:latin typeface="Microsoft YaHei"/>
-                        </a:rPr>
-                        <a:t>多模态(海螺视频/语音)</a:t>
-                      </a:r>
-                    </a:p>
-                  </a:txBody>
-                  <a:tcPr marL="54864" marR="54864" marT="18288" marB="18288" anchor="ctr">
-                    <a:solidFill>
-                      <a:srgbClr val="FFFFFF"/>
-                    </a:solidFill>
-                  </a:tcPr>
-                </a:tc>
-                <a:tc>
-                  <a:txBody>
-                    <a:bodyPr wrap="square"/>
-                    <a:lstStyle/>
-                    <a:p>
-                      <a:pPr algn="l"/>
-                      <a:r>
-                        <a:rPr sz="1250" b="0">
-                          <a:solidFill>
-                            <a:srgbClr val="16213E"/>
-                          </a:solidFill>
-                          <a:latin typeface="Microsoft YaHei"/>
-                        </a:rPr>
-                        <a:t>GLM 系(通用+推理)</a:t>
-                      </a:r>
-                    </a:p>
-                  </a:txBody>
-                  <a:tcPr marL="54864" marR="54864" marT="18288" marB="18288" anchor="ctr">
-                    <a:solidFill>
-                      <a:srgbClr val="FFFFFF"/>
-                    </a:solidFill>
-                  </a:tcPr>
-                </a:tc>
-              </a:tr>
-              <a:tr h="467360">
-                <a:tc>
-                  <a:txBody>
-                    <a:bodyPr wrap="square"/>
-                    <a:lstStyle/>
-                    <a:p>
-                      <a:pPr algn="l"/>
-                      <a:r>
-                        <a:rPr sz="1250" b="0">
-                          <a:solidFill>
-                            <a:srgbClr val="16213E"/>
-                          </a:solidFill>
-                          <a:latin typeface="Microsoft YaHei"/>
-                        </a:rPr>
-                        <a:t>核心风险</a:t>
-                      </a:r>
-                    </a:p>
-                  </a:txBody>
-                  <a:tcPr marL="54864" marR="54864" marT="18288" marB="18288" anchor="ctr">
-                    <a:solidFill>
-                      <a:srgbClr val="E9EBEF"/>
-                    </a:solidFill>
-                  </a:tcPr>
-                </a:tc>
-                <a:tc>
-                  <a:txBody>
-                    <a:bodyPr wrap="square"/>
-                    <a:lstStyle/>
-                    <a:p>
-                      <a:pPr algn="l"/>
-                      <a:r>
-                        <a:rPr sz="1250" b="0">
-                          <a:solidFill>
-                            <a:srgbClr val="16213E"/>
-                          </a:solidFill>
-                          <a:latin typeface="Microsoft YaHei"/>
-                        </a:rPr>
-                        <a:t>C端获客成本 / 海外合规</a:t>
-                      </a:r>
-                    </a:p>
-                  </a:txBody>
-                  <a:tcPr marL="54864" marR="54864" marT="18288" marB="18288" anchor="ctr">
-                    <a:solidFill>
-                      <a:srgbClr val="E9EBEF"/>
-                    </a:solidFill>
-                  </a:tcPr>
-                </a:tc>
-                <a:tc>
-                  <a:txBody>
-                    <a:bodyPr wrap="square"/>
-                    <a:lstStyle/>
-                    <a:p>
-                      <a:pPr algn="l"/>
-                      <a:r>
-                        <a:rPr sz="1250" b="0">
-                          <a:solidFill>
-                            <a:srgbClr val="16213E"/>
-                          </a:solidFill>
-                          <a:latin typeface="Microsoft YaHei"/>
-                        </a:rPr>
-                        <a:t>项目制毛利 / 回款 / G端依赖</a:t>
-                      </a:r>
-                    </a:p>
-                  </a:txBody>
-                  <a:tcPr marL="54864" marR="54864" marT="18288" marB="18288" anchor="ctr">
-                    <a:solidFill>
-                      <a:srgbClr val="E9EBEF"/>
-                    </a:solidFill>
-                  </a:tcPr>
-                </a:tc>
-              </a:tr>
-            </a:tbl>
+          <a:graphicData uri="http://schemas.openxmlformats.org/drawingml/2006/chart">
+            <c:chart xmlns:c="http://schemas.openxmlformats.org/drawingml/2006/chart" r:id="rId2"/>
           </a:graphicData>
         </a:graphic>
       </p:graphicFrame>
       <p:sp>
         <p:nvSpPr>
-          <p:cNvPr id="5" name="TextBox 4"/>
+          <p:cNvPr id="6" name="TextBox 5"/>
+          <p:cNvSpPr txBox="1"/>
+          <p:nvPr/>
+        </p:nvSpPr>
+        <p:spPr>
+          <a:xfrm>
+            <a:off x="6766560" y="1737360"/>
+            <a:ext cx="5029200" cy="4297680"/>
+          </a:xfrm>
+          <a:prstGeom prst="rect">
+            <a:avLst/>
+          </a:prstGeom>
+          <a:noFill/>
+        </p:spPr>
+        <p:txBody>
+          <a:bodyPr wrap="square">
+            <a:spAutoFit/>
+          </a:bodyPr>
+          <a:lstStyle/>
+          <a:p>
+            <a:pPr algn="l">
+              <a:spcAft>
+                <a:spcPts val="700"/>
+              </a:spcAft>
+            </a:pPr>
+            <a:r>
+              <a:rPr sz="1600" b="1">
+                <a:solidFill>
+                  <a:srgbClr val="16213E"/>
+                </a:solidFill>
+                <a:latin typeface="Microsoft YaHei"/>
+              </a:rPr>
+              <a:t>读图要点</a:t>
+            </a:r>
+          </a:p>
+          <a:p>
+            <a:pPr algn="l">
+              <a:spcAft>
+                <a:spcPts val="700"/>
+              </a:spcAft>
+            </a:pPr>
+            <a:r>
+              <a:rPr sz="1400" b="0">
+                <a:solidFill>
+                  <a:srgbClr val="6B707B"/>
+                </a:solidFill>
+                <a:latin typeface="Microsoft YaHei"/>
+              </a:rPr>
+              <a:t>• 2025 营收四家都在 ~$70-100M 区间，绝对体量其实接近（智谱略高、MiniMax 次之）</a:t>
+            </a:r>
+          </a:p>
+          <a:p>
+            <a:pPr algn="l">
+              <a:spcAft>
+                <a:spcPts val="700"/>
+              </a:spcAft>
+            </a:pPr>
+            <a:r>
+              <a:rPr sz="1400" b="0">
+                <a:solidFill>
+                  <a:srgbClr val="6B707B"/>
+                </a:solidFill>
+                <a:latin typeface="Microsoft YaHei"/>
+              </a:rPr>
+              <a:t>• 口径差异大：MiniMax/Kimi/阶跃偏 C 端规模，智谱偏 To B 项目制收入</a:t>
+            </a:r>
+          </a:p>
+          <a:p>
+            <a:pPr algn="l">
+              <a:spcAft>
+                <a:spcPts val="700"/>
+              </a:spcAft>
+            </a:pPr>
+            <a:r>
+              <a:rPr sz="1400" b="0">
+                <a:solidFill>
+                  <a:srgbClr val="6B707B"/>
+                </a:solidFill>
+                <a:latin typeface="Microsoft YaHei"/>
+              </a:rPr>
+              <a:t>• 2026E 增速分化：Kimi &gt;¥20亿(~$278M)、阶跃 ~¥12亿(~$167M)、MiniMax 基准 ~$174M → Kimi 提速最猛</a:t>
+            </a:r>
+          </a:p>
+          <a:p>
+            <a:pPr algn="l">
+              <a:spcAft>
+                <a:spcPts val="700"/>
+              </a:spcAft>
+            </a:pPr>
+            <a:r>
+              <a:rPr sz="1400" b="0">
+                <a:solidFill>
+                  <a:srgbClr val="6B707B"/>
+                </a:solidFill>
+                <a:latin typeface="Microsoft YaHei"/>
+              </a:rPr>
+              <a:t>• 估值与营收倒挂：Kimi 估值($18-30B 报道)远超营收体量 → 市场押的是 Agent 故事</a:t>
+            </a:r>
+          </a:p>
+        </p:txBody>
+      </p:sp>
+      <p:sp>
+        <p:nvSpPr>
+          <p:cNvPr id="7" name="TextBox 6"/>
           <p:cNvSpPr txBox="1"/>
           <p:nvPr/>
         </p:nvSpPr>
@@ -8016,7 +7684,7 @@
                 </a:solidFill>
                 <a:latin typeface="Microsoft YaHei"/>
               </a:rPr>
-              <a:t>来源：MiniMax 招股书；智谱招股书（量子位/智东西解读）。两者口径与币种不同，仅作模式对照</a:t>
+              <a:t>折算率 ¥7.2/US$。MiniMax 为 2025 实际；智谱按 ~130% 增速外推 [E]；Kimi/阶跃为公司/报道口径。跨家口径不完全可比</a:t>
             </a:r>
           </a:p>
         </p:txBody>
@@ -8112,308 +7780,680 @@
                 </a:solidFill>
                 <a:latin typeface="Microsoft YaHei"/>
               </a:rPr>
-              <a:t>综合：护城河在“多模态+出海产品力”，软肋在“流量+盈利”</a:t>
+              <a:t>两条 IPO 路线对照：MiniMax 的 To C 出海 vs 智谱的 To B 政企</a:t>
             </a:r>
           </a:p>
         </p:txBody>
       </p:sp>
-      <p:sp>
-        <p:nvSpPr>
-          <p:cNvPr id="4" name="Rectangle 3"/>
-          <p:cNvSpPr/>
+      <p:graphicFrame>
+        <p:nvGraphicFramePr>
+          <p:cNvPr id="4" name="Table 3"/>
+          <p:cNvGraphicFramePr>
+            <a:graphicFrameLocks noGrp="1"/>
+          </p:cNvGraphicFramePr>
           <p:nvPr/>
-        </p:nvSpPr>
-        <p:spPr>
-          <a:xfrm>
-            <a:off x="457200" y="1600200"/>
-            <a:ext cx="5486400" cy="438912"/>
-          </a:xfrm>
-          <a:prstGeom prst="rect">
-            <a:avLst/>
-          </a:prstGeom>
-          <a:solidFill>
-            <a:srgbClr val="16213E"/>
-          </a:solidFill>
-          <a:ln>
-            <a:noFill/>
-          </a:ln>
-        </p:spPr>
-        <p:style>
-          <a:lnRef idx="1">
-            <a:schemeClr val="accent1"/>
-          </a:lnRef>
-          <a:fillRef idx="3">
-            <a:schemeClr val="accent1"/>
-          </a:fillRef>
-          <a:effectRef idx="2">
-            <a:schemeClr val="accent1"/>
-          </a:effectRef>
-          <a:fontRef idx="minor">
-            <a:schemeClr val="lt1"/>
-          </a:fontRef>
-        </p:style>
-        <p:txBody>
-          <a:bodyPr rtlCol="0" anchor="ctr"/>
-          <a:lstStyle/>
-          <a:p>
-            <a:pPr algn="ctr"/>
-            <a:r>
-              <a:rPr sz="1500" b="1">
-                <a:solidFill>
-                  <a:srgbClr val="FFFFFF"/>
-                </a:solidFill>
-                <a:latin typeface="Microsoft YaHei"/>
-              </a:rPr>
-              <a:t>护城河（可持续优势）</a:t>
-            </a:r>
-          </a:p>
-        </p:txBody>
-      </p:sp>
+        </p:nvGraphicFramePr>
+        <p:xfrm>
+          <a:off x="457200" y="1691640"/>
+          <a:ext cx="11247120" cy="4206240"/>
+        </p:xfrm>
+        <a:graphic>
+          <a:graphicData uri="http://schemas.openxmlformats.org/drawingml/2006/table">
+            <a:tbl>
+              <a:tblPr firstRow="1" bandRow="1">
+                <a:tableStyleId>{5C22544A-7EE6-4342-B048-85BDC9FD1C3A}</a:tableStyleId>
+              </a:tblPr>
+              <a:tblGrid>
+                <a:gridCol w="2103120"/>
+                <a:gridCol w="4572000"/>
+                <a:gridCol w="4572000"/>
+              </a:tblGrid>
+              <a:tr h="467360">
+                <a:tc>
+                  <a:txBody>
+                    <a:bodyPr wrap="square"/>
+                    <a:lstStyle/>
+                    <a:p>
+                      <a:pPr algn="l"/>
+                      <a:r>
+                        <a:rPr sz="1250" b="1">
+                          <a:solidFill>
+                            <a:srgbClr val="FFFFFF"/>
+                          </a:solidFill>
+                          <a:latin typeface="Microsoft YaHei"/>
+                        </a:rPr>
+                        <a:t>维度</a:t>
+                      </a:r>
+                    </a:p>
+                  </a:txBody>
+                  <a:tcPr marL="54864" marR="54864" marT="18288" marB="18288" anchor="ctr">
+                    <a:solidFill>
+                      <a:srgbClr val="16213E"/>
+                    </a:solidFill>
+                  </a:tcPr>
+                </a:tc>
+                <a:tc>
+                  <a:txBody>
+                    <a:bodyPr wrap="square"/>
+                    <a:lstStyle/>
+                    <a:p>
+                      <a:pPr algn="l"/>
+                      <a:r>
+                        <a:rPr sz="1250" b="1">
+                          <a:solidFill>
+                            <a:srgbClr val="FFFFFF"/>
+                          </a:solidFill>
+                          <a:latin typeface="Microsoft YaHei"/>
+                        </a:rPr>
+                        <a:t>MiniMax (00100.HK)</a:t>
+                      </a:r>
+                    </a:p>
+                  </a:txBody>
+                  <a:tcPr marL="54864" marR="54864" marT="18288" marB="18288" anchor="ctr">
+                    <a:solidFill>
+                      <a:srgbClr val="16213E"/>
+                    </a:solidFill>
+                  </a:tcPr>
+                </a:tc>
+                <a:tc>
+                  <a:txBody>
+                    <a:bodyPr wrap="square"/>
+                    <a:lstStyle/>
+                    <a:p>
+                      <a:pPr algn="l"/>
+                      <a:r>
+                        <a:rPr sz="1250" b="1">
+                          <a:solidFill>
+                            <a:srgbClr val="FFFFFF"/>
+                          </a:solidFill>
+                          <a:latin typeface="Microsoft YaHei"/>
+                        </a:rPr>
+                        <a:t>智谱 AI</a:t>
+                      </a:r>
+                    </a:p>
+                  </a:txBody>
+                  <a:tcPr marL="54864" marR="54864" marT="18288" marB="18288" anchor="ctr">
+                    <a:solidFill>
+                      <a:srgbClr val="16213E"/>
+                    </a:solidFill>
+                  </a:tcPr>
+                </a:tc>
+              </a:tr>
+              <a:tr h="467360">
+                <a:tc>
+                  <a:txBody>
+                    <a:bodyPr wrap="square"/>
+                    <a:lstStyle/>
+                    <a:p>
+                      <a:pPr algn="l"/>
+                      <a:r>
+                        <a:rPr sz="1250" b="0">
+                          <a:solidFill>
+                            <a:srgbClr val="16213E"/>
+                          </a:solidFill>
+                          <a:latin typeface="Microsoft YaHei"/>
+                        </a:rPr>
+                        <a:t>客户结构</a:t>
+                      </a:r>
+                    </a:p>
+                  </a:txBody>
+                  <a:tcPr marL="54864" marR="54864" marT="18288" marB="18288" anchor="ctr">
+                    <a:solidFill>
+                      <a:srgbClr val="FFFFFF"/>
+                    </a:solidFill>
+                  </a:tcPr>
+                </a:tc>
+                <a:tc>
+                  <a:txBody>
+                    <a:bodyPr wrap="square"/>
+                    <a:lstStyle/>
+                    <a:p>
+                      <a:pPr algn="l"/>
+                      <a:r>
+                        <a:rPr sz="1250" b="0">
+                          <a:solidFill>
+                            <a:srgbClr val="16213E"/>
+                          </a:solidFill>
+                          <a:latin typeface="Microsoft YaHei"/>
+                        </a:rPr>
+                        <a:t>To C 为主 (~70% 消费级)</a:t>
+                      </a:r>
+                    </a:p>
+                  </a:txBody>
+                  <a:tcPr marL="54864" marR="54864" marT="18288" marB="18288" anchor="ctr">
+                    <a:solidFill>
+                      <a:srgbClr val="FFFFFF"/>
+                    </a:solidFill>
+                  </a:tcPr>
+                </a:tc>
+                <a:tc>
+                  <a:txBody>
+                    <a:bodyPr wrap="square"/>
+                    <a:lstStyle/>
+                    <a:p>
+                      <a:pPr algn="l"/>
+                      <a:r>
+                        <a:rPr sz="1250" b="0">
+                          <a:solidFill>
+                            <a:srgbClr val="16213E"/>
+                          </a:solidFill>
+                          <a:latin typeface="Microsoft YaHei"/>
+                        </a:rPr>
+                        <a:t>To B 为主 (84% 本地化部署)</a:t>
+                      </a:r>
+                    </a:p>
+                  </a:txBody>
+                  <a:tcPr marL="54864" marR="54864" marT="18288" marB="18288" anchor="ctr">
+                    <a:solidFill>
+                      <a:srgbClr val="FFFFFF"/>
+                    </a:solidFill>
+                  </a:tcPr>
+                </a:tc>
+              </a:tr>
+              <a:tr h="467360">
+                <a:tc>
+                  <a:txBody>
+                    <a:bodyPr wrap="square"/>
+                    <a:lstStyle/>
+                    <a:p>
+                      <a:pPr algn="l"/>
+                      <a:r>
+                        <a:rPr sz="1250" b="0">
+                          <a:solidFill>
+                            <a:srgbClr val="16213E"/>
+                          </a:solidFill>
+                          <a:latin typeface="Microsoft YaHei"/>
+                        </a:rPr>
+                        <a:t>市场重心</a:t>
+                      </a:r>
+                    </a:p>
+                  </a:txBody>
+                  <a:tcPr marL="54864" marR="54864" marT="18288" marB="18288" anchor="ctr">
+                    <a:solidFill>
+                      <a:srgbClr val="E9EBEF"/>
+                    </a:solidFill>
+                  </a:tcPr>
+                </a:tc>
+                <a:tc>
+                  <a:txBody>
+                    <a:bodyPr wrap="square"/>
+                    <a:lstStyle/>
+                    <a:p>
+                      <a:pPr algn="l"/>
+                      <a:r>
+                        <a:rPr sz="1250" b="0">
+                          <a:solidFill>
+                            <a:srgbClr val="16213E"/>
+                          </a:solidFill>
+                          <a:latin typeface="Microsoft YaHei"/>
+                        </a:rPr>
+                        <a:t>海外优先 (73% 海外收入)</a:t>
+                      </a:r>
+                    </a:p>
+                  </a:txBody>
+                  <a:tcPr marL="54864" marR="54864" marT="18288" marB="18288" anchor="ctr">
+                    <a:solidFill>
+                      <a:srgbClr val="E9EBEF"/>
+                    </a:solidFill>
+                  </a:tcPr>
+                </a:tc>
+                <a:tc>
+                  <a:txBody>
+                    <a:bodyPr wrap="square"/>
+                    <a:lstStyle/>
+                    <a:p>
+                      <a:pPr algn="l"/>
+                      <a:r>
+                        <a:rPr sz="1250" b="0">
+                          <a:solidFill>
+                            <a:srgbClr val="16213E"/>
+                          </a:solidFill>
+                          <a:latin typeface="Microsoft YaHei"/>
+                        </a:rPr>
+                        <a:t>国内政企 / 国资体系</a:t>
+                      </a:r>
+                    </a:p>
+                  </a:txBody>
+                  <a:tcPr marL="54864" marR="54864" marT="18288" marB="18288" anchor="ctr">
+                    <a:solidFill>
+                      <a:srgbClr val="E9EBEF"/>
+                    </a:solidFill>
+                  </a:tcPr>
+                </a:tc>
+              </a:tr>
+              <a:tr h="467360">
+                <a:tc>
+                  <a:txBody>
+                    <a:bodyPr wrap="square"/>
+                    <a:lstStyle/>
+                    <a:p>
+                      <a:pPr algn="l"/>
+                      <a:r>
+                        <a:rPr sz="1250" b="0">
+                          <a:solidFill>
+                            <a:srgbClr val="16213E"/>
+                          </a:solidFill>
+                          <a:latin typeface="Microsoft YaHei"/>
+                        </a:rPr>
+                        <a:t>营收 (2024)</a:t>
+                      </a:r>
+                    </a:p>
+                  </a:txBody>
+                  <a:tcPr marL="54864" marR="54864" marT="18288" marB="18288" anchor="ctr">
+                    <a:solidFill>
+                      <a:srgbClr val="FFFFFF"/>
+                    </a:solidFill>
+                  </a:tcPr>
+                </a:tc>
+                <a:tc>
+                  <a:txBody>
+                    <a:bodyPr wrap="square"/>
+                    <a:lstStyle/>
+                    <a:p>
+                      <a:pPr algn="l"/>
+                      <a:r>
+                        <a:rPr sz="1250" b="0">
+                          <a:solidFill>
+                            <a:srgbClr val="16213E"/>
+                          </a:solidFill>
+                          <a:latin typeface="Microsoft YaHei"/>
+                        </a:rPr>
+                        <a:t>$30.5M (~¥2.2亿)</a:t>
+                      </a:r>
+                    </a:p>
+                  </a:txBody>
+                  <a:tcPr marL="54864" marR="54864" marT="18288" marB="18288" anchor="ctr">
+                    <a:solidFill>
+                      <a:srgbClr val="FFFFFF"/>
+                    </a:solidFill>
+                  </a:tcPr>
+                </a:tc>
+                <a:tc>
+                  <a:txBody>
+                    <a:bodyPr wrap="square"/>
+                    <a:lstStyle/>
+                    <a:p>
+                      <a:pPr algn="l"/>
+                      <a:r>
+                        <a:rPr sz="1250" b="0">
+                          <a:solidFill>
+                            <a:srgbClr val="16213E"/>
+                          </a:solidFill>
+                          <a:latin typeface="Microsoft YaHei"/>
+                        </a:rPr>
+                        <a:t>¥3.12 亿</a:t>
+                      </a:r>
+                    </a:p>
+                  </a:txBody>
+                  <a:tcPr marL="54864" marR="54864" marT="18288" marB="18288" anchor="ctr">
+                    <a:solidFill>
+                      <a:srgbClr val="FFFFFF"/>
+                    </a:solidFill>
+                  </a:tcPr>
+                </a:tc>
+              </a:tr>
+              <a:tr h="467360">
+                <a:tc>
+                  <a:txBody>
+                    <a:bodyPr wrap="square"/>
+                    <a:lstStyle/>
+                    <a:p>
+                      <a:pPr algn="l"/>
+                      <a:r>
+                        <a:rPr sz="1250" b="0">
+                          <a:solidFill>
+                            <a:srgbClr val="16213E"/>
+                          </a:solidFill>
+                          <a:latin typeface="Microsoft YaHei"/>
+                        </a:rPr>
+                        <a:t>营收增速</a:t>
+                      </a:r>
+                    </a:p>
+                  </a:txBody>
+                  <a:tcPr marL="54864" marR="54864" marT="18288" marB="18288" anchor="ctr">
+                    <a:solidFill>
+                      <a:srgbClr val="E9EBEF"/>
+                    </a:solidFill>
+                  </a:tcPr>
+                </a:tc>
+                <a:tc>
+                  <a:txBody>
+                    <a:bodyPr wrap="square"/>
+                    <a:lstStyle/>
+                    <a:p>
+                      <a:pPr algn="l"/>
+                      <a:r>
+                        <a:rPr sz="1250" b="0">
+                          <a:solidFill>
+                            <a:srgbClr val="16213E"/>
+                          </a:solidFill>
+                          <a:latin typeface="Microsoft YaHei"/>
+                        </a:rPr>
+                        <a:t>2025 +159%</a:t>
+                      </a:r>
+                    </a:p>
+                  </a:txBody>
+                  <a:tcPr marL="54864" marR="54864" marT="18288" marB="18288" anchor="ctr">
+                    <a:solidFill>
+                      <a:srgbClr val="E9EBEF"/>
+                    </a:solidFill>
+                  </a:tcPr>
+                </a:tc>
+                <a:tc>
+                  <a:txBody>
+                    <a:bodyPr wrap="square"/>
+                    <a:lstStyle/>
+                    <a:p>
+                      <a:pPr algn="l"/>
+                      <a:r>
+                        <a:rPr sz="1250" b="0">
+                          <a:solidFill>
+                            <a:srgbClr val="16213E"/>
+                          </a:solidFill>
+                          <a:latin typeface="Microsoft YaHei"/>
+                        </a:rPr>
+                        <a:t>三年 CAGR ~130%</a:t>
+                      </a:r>
+                    </a:p>
+                  </a:txBody>
+                  <a:tcPr marL="54864" marR="54864" marT="18288" marB="18288" anchor="ctr">
+                    <a:solidFill>
+                      <a:srgbClr val="E9EBEF"/>
+                    </a:solidFill>
+                  </a:tcPr>
+                </a:tc>
+              </a:tr>
+              <a:tr h="467360">
+                <a:tc>
+                  <a:txBody>
+                    <a:bodyPr wrap="square"/>
+                    <a:lstStyle/>
+                    <a:p>
+                      <a:pPr algn="l"/>
+                      <a:r>
+                        <a:rPr sz="1250" b="0">
+                          <a:solidFill>
+                            <a:srgbClr val="16213E"/>
+                          </a:solidFill>
+                          <a:latin typeface="Microsoft YaHei"/>
+                        </a:rPr>
+                        <a:t>估值</a:t>
+                      </a:r>
+                    </a:p>
+                  </a:txBody>
+                  <a:tcPr marL="54864" marR="54864" marT="18288" marB="18288" anchor="ctr">
+                    <a:solidFill>
+                      <a:srgbClr val="FFFFFF"/>
+                    </a:solidFill>
+                  </a:tcPr>
+                </a:tc>
+                <a:tc>
+                  <a:txBody>
+                    <a:bodyPr wrap="square"/>
+                    <a:lstStyle/>
+                    <a:p>
+                      <a:pPr algn="l"/>
+                      <a:r>
+                        <a:rPr sz="1250" b="0">
+                          <a:solidFill>
+                            <a:srgbClr val="16213E"/>
+                          </a:solidFill>
+                          <a:latin typeface="Microsoft YaHei"/>
+                        </a:rPr>
+                        <a:t>≈ US$5.9B (上市市值)</a:t>
+                      </a:r>
+                    </a:p>
+                  </a:txBody>
+                  <a:tcPr marL="54864" marR="54864" marT="18288" marB="18288" anchor="ctr">
+                    <a:solidFill>
+                      <a:srgbClr val="FFFFFF"/>
+                    </a:solidFill>
+                  </a:tcPr>
+                </a:tc>
+                <a:tc>
+                  <a:txBody>
+                    <a:bodyPr wrap="square"/>
+                    <a:lstStyle/>
+                    <a:p>
+                      <a:pPr algn="l"/>
+                      <a:r>
+                        <a:rPr sz="1250" b="0">
+                          <a:solidFill>
+                            <a:srgbClr val="16213E"/>
+                          </a:solidFill>
+                          <a:latin typeface="Microsoft YaHei"/>
+                        </a:rPr>
+                        <a:t>≈ ¥244 亿 (~$3.4B)</a:t>
+                      </a:r>
+                    </a:p>
+                  </a:txBody>
+                  <a:tcPr marL="54864" marR="54864" marT="18288" marB="18288" anchor="ctr">
+                    <a:solidFill>
+                      <a:srgbClr val="FFFFFF"/>
+                    </a:solidFill>
+                  </a:tcPr>
+                </a:tc>
+              </a:tr>
+              <a:tr h="467360">
+                <a:tc>
+                  <a:txBody>
+                    <a:bodyPr wrap="square"/>
+                    <a:lstStyle/>
+                    <a:p>
+                      <a:pPr algn="l"/>
+                      <a:r>
+                        <a:rPr sz="1250" b="0">
+                          <a:solidFill>
+                            <a:srgbClr val="16213E"/>
+                          </a:solidFill>
+                          <a:latin typeface="Microsoft YaHei"/>
+                        </a:rPr>
+                        <a:t>上市进度</a:t>
+                      </a:r>
+                    </a:p>
+                  </a:txBody>
+                  <a:tcPr marL="54864" marR="54864" marT="18288" marB="18288" anchor="ctr">
+                    <a:solidFill>
+                      <a:srgbClr val="E9EBEF"/>
+                    </a:solidFill>
+                  </a:tcPr>
+                </a:tc>
+                <a:tc>
+                  <a:txBody>
+                    <a:bodyPr wrap="square"/>
+                    <a:lstStyle/>
+                    <a:p>
+                      <a:pPr algn="l"/>
+                      <a:r>
+                        <a:rPr sz="1250" b="0">
+                          <a:solidFill>
+                            <a:srgbClr val="16213E"/>
+                          </a:solidFill>
+                          <a:latin typeface="Microsoft YaHei"/>
+                        </a:rPr>
+                        <a:t>已上市 2026-01-09</a:t>
+                      </a:r>
+                    </a:p>
+                  </a:txBody>
+                  <a:tcPr marL="54864" marR="54864" marT="18288" marB="18288" anchor="ctr">
+                    <a:solidFill>
+                      <a:srgbClr val="E9EBEF"/>
+                    </a:solidFill>
+                  </a:tcPr>
+                </a:tc>
+                <a:tc>
+                  <a:txBody>
+                    <a:bodyPr wrap="square"/>
+                    <a:lstStyle/>
+                    <a:p>
+                      <a:pPr algn="l"/>
+                      <a:r>
+                        <a:rPr sz="1250" b="0">
+                          <a:solidFill>
+                            <a:srgbClr val="16213E"/>
+                          </a:solidFill>
+                          <a:latin typeface="Microsoft YaHei"/>
+                        </a:rPr>
+                        <a:t>通过聆讯，冲“第一股”</a:t>
+                      </a:r>
+                    </a:p>
+                  </a:txBody>
+                  <a:tcPr marL="54864" marR="54864" marT="18288" marB="18288" anchor="ctr">
+                    <a:solidFill>
+                      <a:srgbClr val="E9EBEF"/>
+                    </a:solidFill>
+                  </a:tcPr>
+                </a:tc>
+              </a:tr>
+              <a:tr h="467360">
+                <a:tc>
+                  <a:txBody>
+                    <a:bodyPr wrap="square"/>
+                    <a:lstStyle/>
+                    <a:p>
+                      <a:pPr algn="l"/>
+                      <a:r>
+                        <a:rPr sz="1250" b="0">
+                          <a:solidFill>
+                            <a:srgbClr val="16213E"/>
+                          </a:solidFill>
+                          <a:latin typeface="Microsoft YaHei"/>
+                        </a:rPr>
+                        <a:t>代表模型</a:t>
+                      </a:r>
+                    </a:p>
+                  </a:txBody>
+                  <a:tcPr marL="54864" marR="54864" marT="18288" marB="18288" anchor="ctr">
+                    <a:solidFill>
+                      <a:srgbClr val="FFFFFF"/>
+                    </a:solidFill>
+                  </a:tcPr>
+                </a:tc>
+                <a:tc>
+                  <a:txBody>
+                    <a:bodyPr wrap="square"/>
+                    <a:lstStyle/>
+                    <a:p>
+                      <a:pPr algn="l"/>
+                      <a:r>
+                        <a:rPr sz="1250" b="0">
+                          <a:solidFill>
+                            <a:srgbClr val="16213E"/>
+                          </a:solidFill>
+                          <a:latin typeface="Microsoft YaHei"/>
+                        </a:rPr>
+                        <a:t>多模态(海螺视频/语音)</a:t>
+                      </a:r>
+                    </a:p>
+                  </a:txBody>
+                  <a:tcPr marL="54864" marR="54864" marT="18288" marB="18288" anchor="ctr">
+                    <a:solidFill>
+                      <a:srgbClr val="FFFFFF"/>
+                    </a:solidFill>
+                  </a:tcPr>
+                </a:tc>
+                <a:tc>
+                  <a:txBody>
+                    <a:bodyPr wrap="square"/>
+                    <a:lstStyle/>
+                    <a:p>
+                      <a:pPr algn="l"/>
+                      <a:r>
+                        <a:rPr sz="1250" b="0">
+                          <a:solidFill>
+                            <a:srgbClr val="16213E"/>
+                          </a:solidFill>
+                          <a:latin typeface="Microsoft YaHei"/>
+                        </a:rPr>
+                        <a:t>GLM 系(通用+推理)</a:t>
+                      </a:r>
+                    </a:p>
+                  </a:txBody>
+                  <a:tcPr marL="54864" marR="54864" marT="18288" marB="18288" anchor="ctr">
+                    <a:solidFill>
+                      <a:srgbClr val="FFFFFF"/>
+                    </a:solidFill>
+                  </a:tcPr>
+                </a:tc>
+              </a:tr>
+              <a:tr h="467360">
+                <a:tc>
+                  <a:txBody>
+                    <a:bodyPr wrap="square"/>
+                    <a:lstStyle/>
+                    <a:p>
+                      <a:pPr algn="l"/>
+                      <a:r>
+                        <a:rPr sz="1250" b="0">
+                          <a:solidFill>
+                            <a:srgbClr val="16213E"/>
+                          </a:solidFill>
+                          <a:latin typeface="Microsoft YaHei"/>
+                        </a:rPr>
+                        <a:t>核心风险</a:t>
+                      </a:r>
+                    </a:p>
+                  </a:txBody>
+                  <a:tcPr marL="54864" marR="54864" marT="18288" marB="18288" anchor="ctr">
+                    <a:solidFill>
+                      <a:srgbClr val="E9EBEF"/>
+                    </a:solidFill>
+                  </a:tcPr>
+                </a:tc>
+                <a:tc>
+                  <a:txBody>
+                    <a:bodyPr wrap="square"/>
+                    <a:lstStyle/>
+                    <a:p>
+                      <a:pPr algn="l"/>
+                      <a:r>
+                        <a:rPr sz="1250" b="0">
+                          <a:solidFill>
+                            <a:srgbClr val="16213E"/>
+                          </a:solidFill>
+                          <a:latin typeface="Microsoft YaHei"/>
+                        </a:rPr>
+                        <a:t>C端获客成本 / 海外合规</a:t>
+                      </a:r>
+                    </a:p>
+                  </a:txBody>
+                  <a:tcPr marL="54864" marR="54864" marT="18288" marB="18288" anchor="ctr">
+                    <a:solidFill>
+                      <a:srgbClr val="E9EBEF"/>
+                    </a:solidFill>
+                  </a:tcPr>
+                </a:tc>
+                <a:tc>
+                  <a:txBody>
+                    <a:bodyPr wrap="square"/>
+                    <a:lstStyle/>
+                    <a:p>
+                      <a:pPr algn="l"/>
+                      <a:r>
+                        <a:rPr sz="1250" b="0">
+                          <a:solidFill>
+                            <a:srgbClr val="16213E"/>
+                          </a:solidFill>
+                          <a:latin typeface="Microsoft YaHei"/>
+                        </a:rPr>
+                        <a:t>项目制毛利 / 回款 / G端依赖</a:t>
+                      </a:r>
+                    </a:p>
+                  </a:txBody>
+                  <a:tcPr marL="54864" marR="54864" marT="18288" marB="18288" anchor="ctr">
+                    <a:solidFill>
+                      <a:srgbClr val="E9EBEF"/>
+                    </a:solidFill>
+                  </a:tcPr>
+                </a:tc>
+              </a:tr>
+            </a:tbl>
+          </a:graphicData>
+        </a:graphic>
+      </p:graphicFrame>
       <p:sp>
         <p:nvSpPr>
           <p:cNvPr id="5" name="TextBox 4"/>
-          <p:cNvSpPr txBox="1"/>
-          <p:nvPr/>
-        </p:nvSpPr>
-        <p:spPr>
-          <a:xfrm>
-            <a:off x="457200" y="2103120"/>
-            <a:ext cx="5486400" cy="3840480"/>
-          </a:xfrm>
-          <a:prstGeom prst="rect">
-            <a:avLst/>
-          </a:prstGeom>
-          <a:noFill/>
-        </p:spPr>
-        <p:txBody>
-          <a:bodyPr wrap="square">
-            <a:spAutoFit/>
-          </a:bodyPr>
-          <a:lstStyle/>
-          <a:p>
-            <a:pPr algn="l">
-              <a:spcAft>
-                <a:spcPts val="700"/>
-              </a:spcAft>
-            </a:pPr>
-            <a:r>
-              <a:rPr sz="1400" b="0">
-                <a:solidFill>
-                  <a:srgbClr val="6B707B"/>
-                </a:solidFill>
-                <a:latin typeface="Microsoft YaHei"/>
-              </a:rPr>
-              <a:t>• 产品力：海螺/Talkie 在 AI 视频与情感陪伴的海外心智</a:t>
-            </a:r>
-          </a:p>
-          <a:p>
-            <a:pPr algn="l">
-              <a:spcAft>
-                <a:spcPts val="700"/>
-              </a:spcAft>
-            </a:pPr>
-            <a:r>
-              <a:rPr sz="1400" b="0">
-                <a:solidFill>
-                  <a:srgbClr val="6B707B"/>
-                </a:solidFill>
-                <a:latin typeface="Microsoft YaHei"/>
-              </a:rPr>
-              <a:t>• 多模态全栈自研，模型迭代快（M2.5、Hailuo-02）</a:t>
-            </a:r>
-          </a:p>
-          <a:p>
-            <a:pPr algn="l">
-              <a:spcAft>
-                <a:spcPts val="700"/>
-              </a:spcAft>
-            </a:pPr>
-            <a:r>
-              <a:rPr sz="1400" b="0">
-                <a:solidFill>
-                  <a:srgbClr val="6B707B"/>
-                </a:solidFill>
-                <a:latin typeface="Microsoft YaHei"/>
-              </a:rPr>
-              <a:t>• 出海先发：73% 海外收入，绕开国内流量血战</a:t>
-            </a:r>
-          </a:p>
-          <a:p>
-            <a:pPr algn="l">
-              <a:spcAft>
-                <a:spcPts val="700"/>
-              </a:spcAft>
-            </a:pPr>
-            <a:r>
-              <a:rPr sz="1400" b="0">
-                <a:solidFill>
-                  <a:srgbClr val="6B707B"/>
-                </a:solidFill>
-                <a:latin typeface="Microsoft YaHei"/>
-              </a:rPr>
-              <a:t>• 资本/生态：阿里、腾讯、米哈游战略加持</a:t>
-            </a:r>
-          </a:p>
-        </p:txBody>
-      </p:sp>
-      <p:sp>
-        <p:nvSpPr>
-          <p:cNvPr id="6" name="Rectangle 5"/>
-          <p:cNvSpPr/>
-          <p:nvPr/>
-        </p:nvSpPr>
-        <p:spPr>
-          <a:xfrm>
-            <a:off x="6309360" y="1600200"/>
-            <a:ext cx="5486400" cy="438912"/>
-          </a:xfrm>
-          <a:prstGeom prst="rect">
-            <a:avLst/>
-          </a:prstGeom>
-          <a:solidFill>
-            <a:srgbClr val="2E86C1"/>
-          </a:solidFill>
-          <a:ln>
-            <a:noFill/>
-          </a:ln>
-        </p:spPr>
-        <p:style>
-          <a:lnRef idx="1">
-            <a:schemeClr val="accent1"/>
-          </a:lnRef>
-          <a:fillRef idx="3">
-            <a:schemeClr val="accent1"/>
-          </a:fillRef>
-          <a:effectRef idx="2">
-            <a:schemeClr val="accent1"/>
-          </a:effectRef>
-          <a:fontRef idx="minor">
-            <a:schemeClr val="lt1"/>
-          </a:fontRef>
-        </p:style>
-        <p:txBody>
-          <a:bodyPr rtlCol="0" anchor="ctr"/>
-          <a:lstStyle/>
-          <a:p>
-            <a:pPr algn="ctr"/>
-            <a:r>
-              <a:rPr sz="1500" b="1">
-                <a:solidFill>
-                  <a:srgbClr val="FFFFFF"/>
-                </a:solidFill>
-                <a:latin typeface="Microsoft YaHei"/>
-              </a:rPr>
-              <a:t>软肋（结构性风险）</a:t>
-            </a:r>
-          </a:p>
-        </p:txBody>
-      </p:sp>
-      <p:sp>
-        <p:nvSpPr>
-          <p:cNvPr id="7" name="TextBox 6"/>
-          <p:cNvSpPr txBox="1"/>
-          <p:nvPr/>
-        </p:nvSpPr>
-        <p:spPr>
-          <a:xfrm>
-            <a:off x="6309360" y="2103120"/>
-            <a:ext cx="5486400" cy="3840480"/>
-          </a:xfrm>
-          <a:prstGeom prst="rect">
-            <a:avLst/>
-          </a:prstGeom>
-          <a:noFill/>
-        </p:spPr>
-        <p:txBody>
-          <a:bodyPr wrap="square">
-            <a:spAutoFit/>
-          </a:bodyPr>
-          <a:lstStyle/>
-          <a:p>
-            <a:pPr algn="l">
-              <a:spcAft>
-                <a:spcPts val="700"/>
-              </a:spcAft>
-            </a:pPr>
-            <a:r>
-              <a:rPr sz="1400" b="0">
-                <a:solidFill>
-                  <a:srgbClr val="6B707B"/>
-                </a:solidFill>
-                <a:latin typeface="Microsoft YaHei"/>
-              </a:rPr>
-              <a:t>• 持续大额亏损，盈利路径与时点未明</a:t>
-            </a:r>
-          </a:p>
-          <a:p>
-            <a:pPr algn="l">
-              <a:spcAft>
-                <a:spcPts val="700"/>
-              </a:spcAft>
-            </a:pPr>
-            <a:r>
-              <a:rPr sz="1400" b="0">
-                <a:solidFill>
-                  <a:srgbClr val="6B707B"/>
-                </a:solidFill>
-                <a:latin typeface="Microsoft YaHei"/>
-              </a:rPr>
-              <a:t>• 国内流量远逊大厂，C 端获客成本高</a:t>
-            </a:r>
-          </a:p>
-          <a:p>
-            <a:pPr algn="l">
-              <a:spcAft>
-                <a:spcPts val="700"/>
-              </a:spcAft>
-            </a:pPr>
-            <a:r>
-              <a:rPr sz="1400" b="0">
-                <a:solidFill>
-                  <a:srgbClr val="6B707B"/>
-                </a:solidFill>
-                <a:latin typeface="Microsoft YaHei"/>
-              </a:rPr>
-              <a:t>• 估值 75x P/S，容错空间极小</a:t>
-            </a:r>
-          </a:p>
-          <a:p>
-            <a:pPr algn="l">
-              <a:spcAft>
-                <a:spcPts val="700"/>
-              </a:spcAft>
-            </a:pPr>
-            <a:r>
-              <a:rPr sz="1400" b="0">
-                <a:solidFill>
-                  <a:srgbClr val="6B707B"/>
-                </a:solidFill>
-                <a:latin typeface="Microsoft YaHei"/>
-              </a:rPr>
-              <a:t>• 海外合规/地缘 + 开源模型挤压付费意愿</a:t>
-            </a:r>
-          </a:p>
-          <a:p>
-            <a:pPr algn="l">
-              <a:spcAft>
-                <a:spcPts val="700"/>
-              </a:spcAft>
-            </a:pPr>
-            <a:r>
-              <a:rPr sz="1400" b="0">
-                <a:solidFill>
-                  <a:srgbClr val="6B707B"/>
-                </a:solidFill>
-                <a:latin typeface="Microsoft YaHei"/>
-              </a:rPr>
-              <a:t>• 阿里等股东同时是竞品（豆包/Qwen/智谱）</a:t>
-            </a:r>
-          </a:p>
-        </p:txBody>
-      </p:sp>
-      <p:sp>
-        <p:nvSpPr>
-          <p:cNvPr id="8" name="TextBox 7"/>
           <p:cNvSpPr txBox="1"/>
           <p:nvPr/>
         </p:nvSpPr>
@@ -8441,7 +8481,7 @@
                 </a:solidFill>
                 <a:latin typeface="Microsoft YaHei"/>
               </a:rPr>
-              <a:t>综合招股书、券商研报与公开报道的作者判断</a:t>
+              <a:t>来源：MiniMax 招股书；智谱招股书（量子位/智东西解读）。两者口径与币种不同，仅作模式对照</a:t>
             </a:r>
           </a:p>
         </p:txBody>
@@ -8537,6 +8577,431 @@
                 </a:solidFill>
                 <a:latin typeface="Microsoft YaHei"/>
               </a:rPr>
+              <a:t>综合：护城河在“多模态+出海产品力”，软肋在“流量+盈利”</a:t>
+            </a:r>
+          </a:p>
+        </p:txBody>
+      </p:sp>
+      <p:sp>
+        <p:nvSpPr>
+          <p:cNvPr id="4" name="Rectangle 3"/>
+          <p:cNvSpPr/>
+          <p:nvPr/>
+        </p:nvSpPr>
+        <p:spPr>
+          <a:xfrm>
+            <a:off x="457200" y="1600200"/>
+            <a:ext cx="5486400" cy="438912"/>
+          </a:xfrm>
+          <a:prstGeom prst="rect">
+            <a:avLst/>
+          </a:prstGeom>
+          <a:solidFill>
+            <a:srgbClr val="16213E"/>
+          </a:solidFill>
+          <a:ln>
+            <a:noFill/>
+          </a:ln>
+        </p:spPr>
+        <p:style>
+          <a:lnRef idx="1">
+            <a:schemeClr val="accent1"/>
+          </a:lnRef>
+          <a:fillRef idx="3">
+            <a:schemeClr val="accent1"/>
+          </a:fillRef>
+          <a:effectRef idx="2">
+            <a:schemeClr val="accent1"/>
+          </a:effectRef>
+          <a:fontRef idx="minor">
+            <a:schemeClr val="lt1"/>
+          </a:fontRef>
+        </p:style>
+        <p:txBody>
+          <a:bodyPr rtlCol="0" anchor="ctr"/>
+          <a:lstStyle/>
+          <a:p>
+            <a:pPr algn="ctr"/>
+            <a:r>
+              <a:rPr sz="1500" b="1">
+                <a:solidFill>
+                  <a:srgbClr val="FFFFFF"/>
+                </a:solidFill>
+                <a:latin typeface="Microsoft YaHei"/>
+              </a:rPr>
+              <a:t>护城河（可持续优势）</a:t>
+            </a:r>
+          </a:p>
+        </p:txBody>
+      </p:sp>
+      <p:sp>
+        <p:nvSpPr>
+          <p:cNvPr id="5" name="TextBox 4"/>
+          <p:cNvSpPr txBox="1"/>
+          <p:nvPr/>
+        </p:nvSpPr>
+        <p:spPr>
+          <a:xfrm>
+            <a:off x="457200" y="2103120"/>
+            <a:ext cx="5486400" cy="3840480"/>
+          </a:xfrm>
+          <a:prstGeom prst="rect">
+            <a:avLst/>
+          </a:prstGeom>
+          <a:noFill/>
+        </p:spPr>
+        <p:txBody>
+          <a:bodyPr wrap="square">
+            <a:spAutoFit/>
+          </a:bodyPr>
+          <a:lstStyle/>
+          <a:p>
+            <a:pPr algn="l">
+              <a:spcAft>
+                <a:spcPts val="700"/>
+              </a:spcAft>
+            </a:pPr>
+            <a:r>
+              <a:rPr sz="1400" b="0">
+                <a:solidFill>
+                  <a:srgbClr val="6B707B"/>
+                </a:solidFill>
+                <a:latin typeface="Microsoft YaHei"/>
+              </a:rPr>
+              <a:t>• 产品力：海螺/Talkie 在 AI 视频与情感陪伴的海外心智</a:t>
+            </a:r>
+          </a:p>
+          <a:p>
+            <a:pPr algn="l">
+              <a:spcAft>
+                <a:spcPts val="700"/>
+              </a:spcAft>
+            </a:pPr>
+            <a:r>
+              <a:rPr sz="1400" b="0">
+                <a:solidFill>
+                  <a:srgbClr val="6B707B"/>
+                </a:solidFill>
+                <a:latin typeface="Microsoft YaHei"/>
+              </a:rPr>
+              <a:t>• 多模态全栈自研，模型迭代快（M2.5、Hailuo-02）</a:t>
+            </a:r>
+          </a:p>
+          <a:p>
+            <a:pPr algn="l">
+              <a:spcAft>
+                <a:spcPts val="700"/>
+              </a:spcAft>
+            </a:pPr>
+            <a:r>
+              <a:rPr sz="1400" b="0">
+                <a:solidFill>
+                  <a:srgbClr val="6B707B"/>
+                </a:solidFill>
+                <a:latin typeface="Microsoft YaHei"/>
+              </a:rPr>
+              <a:t>• 出海先发：73% 海外收入，绕开国内流量血战</a:t>
+            </a:r>
+          </a:p>
+          <a:p>
+            <a:pPr algn="l">
+              <a:spcAft>
+                <a:spcPts val="700"/>
+              </a:spcAft>
+            </a:pPr>
+            <a:r>
+              <a:rPr sz="1400" b="0">
+                <a:solidFill>
+                  <a:srgbClr val="6B707B"/>
+                </a:solidFill>
+                <a:latin typeface="Microsoft YaHei"/>
+              </a:rPr>
+              <a:t>• 资本/生态：阿里、腾讯、米哈游战略加持</a:t>
+            </a:r>
+          </a:p>
+        </p:txBody>
+      </p:sp>
+      <p:sp>
+        <p:nvSpPr>
+          <p:cNvPr id="6" name="Rectangle 5"/>
+          <p:cNvSpPr/>
+          <p:nvPr/>
+        </p:nvSpPr>
+        <p:spPr>
+          <a:xfrm>
+            <a:off x="6309360" y="1600200"/>
+            <a:ext cx="5486400" cy="438912"/>
+          </a:xfrm>
+          <a:prstGeom prst="rect">
+            <a:avLst/>
+          </a:prstGeom>
+          <a:solidFill>
+            <a:srgbClr val="2E86C1"/>
+          </a:solidFill>
+          <a:ln>
+            <a:noFill/>
+          </a:ln>
+        </p:spPr>
+        <p:style>
+          <a:lnRef idx="1">
+            <a:schemeClr val="accent1"/>
+          </a:lnRef>
+          <a:fillRef idx="3">
+            <a:schemeClr val="accent1"/>
+          </a:fillRef>
+          <a:effectRef idx="2">
+            <a:schemeClr val="accent1"/>
+          </a:effectRef>
+          <a:fontRef idx="minor">
+            <a:schemeClr val="lt1"/>
+          </a:fontRef>
+        </p:style>
+        <p:txBody>
+          <a:bodyPr rtlCol="0" anchor="ctr"/>
+          <a:lstStyle/>
+          <a:p>
+            <a:pPr algn="ctr"/>
+            <a:r>
+              <a:rPr sz="1500" b="1">
+                <a:solidFill>
+                  <a:srgbClr val="FFFFFF"/>
+                </a:solidFill>
+                <a:latin typeface="Microsoft YaHei"/>
+              </a:rPr>
+              <a:t>软肋（结构性风险）</a:t>
+            </a:r>
+          </a:p>
+        </p:txBody>
+      </p:sp>
+      <p:sp>
+        <p:nvSpPr>
+          <p:cNvPr id="7" name="TextBox 6"/>
+          <p:cNvSpPr txBox="1"/>
+          <p:nvPr/>
+        </p:nvSpPr>
+        <p:spPr>
+          <a:xfrm>
+            <a:off x="6309360" y="2103120"/>
+            <a:ext cx="5486400" cy="3840480"/>
+          </a:xfrm>
+          <a:prstGeom prst="rect">
+            <a:avLst/>
+          </a:prstGeom>
+          <a:noFill/>
+        </p:spPr>
+        <p:txBody>
+          <a:bodyPr wrap="square">
+            <a:spAutoFit/>
+          </a:bodyPr>
+          <a:lstStyle/>
+          <a:p>
+            <a:pPr algn="l">
+              <a:spcAft>
+                <a:spcPts val="700"/>
+              </a:spcAft>
+            </a:pPr>
+            <a:r>
+              <a:rPr sz="1400" b="0">
+                <a:solidFill>
+                  <a:srgbClr val="6B707B"/>
+                </a:solidFill>
+                <a:latin typeface="Microsoft YaHei"/>
+              </a:rPr>
+              <a:t>• 持续大额亏损，盈利路径与时点未明</a:t>
+            </a:r>
+          </a:p>
+          <a:p>
+            <a:pPr algn="l">
+              <a:spcAft>
+                <a:spcPts val="700"/>
+              </a:spcAft>
+            </a:pPr>
+            <a:r>
+              <a:rPr sz="1400" b="0">
+                <a:solidFill>
+                  <a:srgbClr val="6B707B"/>
+                </a:solidFill>
+                <a:latin typeface="Microsoft YaHei"/>
+              </a:rPr>
+              <a:t>• 国内流量远逊大厂，C 端获客成本高</a:t>
+            </a:r>
+          </a:p>
+          <a:p>
+            <a:pPr algn="l">
+              <a:spcAft>
+                <a:spcPts val="700"/>
+              </a:spcAft>
+            </a:pPr>
+            <a:r>
+              <a:rPr sz="1400" b="0">
+                <a:solidFill>
+                  <a:srgbClr val="6B707B"/>
+                </a:solidFill>
+                <a:latin typeface="Microsoft YaHei"/>
+              </a:rPr>
+              <a:t>• 估值 75x P/S，容错空间极小</a:t>
+            </a:r>
+          </a:p>
+          <a:p>
+            <a:pPr algn="l">
+              <a:spcAft>
+                <a:spcPts val="700"/>
+              </a:spcAft>
+            </a:pPr>
+            <a:r>
+              <a:rPr sz="1400" b="0">
+                <a:solidFill>
+                  <a:srgbClr val="6B707B"/>
+                </a:solidFill>
+                <a:latin typeface="Microsoft YaHei"/>
+              </a:rPr>
+              <a:t>• 海外合规/地缘 + 开源模型挤压付费意愿</a:t>
+            </a:r>
+          </a:p>
+          <a:p>
+            <a:pPr algn="l">
+              <a:spcAft>
+                <a:spcPts val="700"/>
+              </a:spcAft>
+            </a:pPr>
+            <a:r>
+              <a:rPr sz="1400" b="0">
+                <a:solidFill>
+                  <a:srgbClr val="6B707B"/>
+                </a:solidFill>
+                <a:latin typeface="Microsoft YaHei"/>
+              </a:rPr>
+              <a:t>• 阿里等股东同时是竞品（豆包/Qwen/智谱）</a:t>
+            </a:r>
+          </a:p>
+        </p:txBody>
+      </p:sp>
+      <p:sp>
+        <p:nvSpPr>
+          <p:cNvPr id="8" name="TextBox 7"/>
+          <p:cNvSpPr txBox="1"/>
+          <p:nvPr/>
+        </p:nvSpPr>
+        <p:spPr>
+          <a:xfrm>
+            <a:off x="457200" y="6455664"/>
+            <a:ext cx="11338560" cy="365760"/>
+          </a:xfrm>
+          <a:prstGeom prst="rect">
+            <a:avLst/>
+          </a:prstGeom>
+          <a:noFill/>
+        </p:spPr>
+        <p:txBody>
+          <a:bodyPr wrap="square">
+            <a:spAutoFit/>
+          </a:bodyPr>
+          <a:lstStyle/>
+          <a:p>
+            <a:pPr algn="l"/>
+            <a:r>
+              <a:rPr sz="900" b="0">
+                <a:solidFill>
+                  <a:srgbClr val="6B707B"/>
+                </a:solidFill>
+                <a:latin typeface="Microsoft YaHei"/>
+              </a:rPr>
+              <a:t>综合招股书、券商研报与公开报道的作者判断</a:t>
+            </a:r>
+          </a:p>
+        </p:txBody>
+      </p:sp>
+    </p:spTree>
+  </p:cSld>
+  <p:clrMapOvr>
+    <a:masterClrMapping/>
+  </p:clrMapOvr>
+</p:sld>
+</file>
+
+<file path=ppt/slides/slide18.xml><?xml version="1.0" encoding="utf-8"?>
+<p:sld xmlns:a="http://schemas.openxmlformats.org/drawingml/2006/main" xmlns:p="http://schemas.openxmlformats.org/presentationml/2006/main" xmlns:r="http://schemas.openxmlformats.org/officeDocument/2006/relationships">
+  <p:cSld>
+    <p:spTree>
+      <p:nvGrpSpPr>
+        <p:cNvPr id="1" name=""/>
+        <p:cNvGrpSpPr/>
+        <p:nvPr/>
+      </p:nvGrpSpPr>
+      <p:grpSpPr/>
+      <p:sp>
+        <p:nvSpPr>
+          <p:cNvPr id="2" name="Rectangle 1"/>
+          <p:cNvSpPr/>
+          <p:nvPr/>
+        </p:nvSpPr>
+        <p:spPr>
+          <a:xfrm>
+            <a:off x="0" y="0"/>
+            <a:ext cx="12191695" cy="109728"/>
+          </a:xfrm>
+          <a:prstGeom prst="rect">
+            <a:avLst/>
+          </a:prstGeom>
+          <a:solidFill>
+            <a:srgbClr val="2E86C1"/>
+          </a:solidFill>
+          <a:ln>
+            <a:noFill/>
+          </a:ln>
+        </p:spPr>
+        <p:style>
+          <a:lnRef idx="1">
+            <a:schemeClr val="accent1"/>
+          </a:lnRef>
+          <a:fillRef idx="3">
+            <a:schemeClr val="accent1"/>
+          </a:fillRef>
+          <a:effectRef idx="2">
+            <a:schemeClr val="accent1"/>
+          </a:effectRef>
+          <a:fontRef idx="minor">
+            <a:schemeClr val="lt1"/>
+          </a:fontRef>
+        </p:style>
+        <p:txBody>
+          <a:bodyPr rtlCol="0" anchor="ctr"/>
+          <a:lstStyle/>
+          <a:p>
+            <a:pPr algn="ctr"/>
+          </a:p>
+        </p:txBody>
+      </p:sp>
+      <p:sp>
+        <p:nvSpPr>
+          <p:cNvPr id="3" name="TextBox 2"/>
+          <p:cNvSpPr txBox="1"/>
+          <p:nvPr/>
+        </p:nvSpPr>
+        <p:spPr>
+          <a:xfrm>
+            <a:off x="457200" y="219456"/>
+            <a:ext cx="11338560" cy="914400"/>
+          </a:xfrm>
+          <a:prstGeom prst="rect">
+            <a:avLst/>
+          </a:prstGeom>
+          <a:noFill/>
+        </p:spPr>
+        <p:txBody>
+          <a:bodyPr wrap="square">
+            <a:spAutoFit/>
+          </a:bodyPr>
+          <a:lstStyle/>
+          <a:p>
+            <a:pPr algn="l"/>
+            <a:r>
+              <a:rPr sz="2500" b="1">
+                <a:solidFill>
+                  <a:srgbClr val="16213E"/>
+                </a:solidFill>
+                <a:latin typeface="Microsoft YaHei"/>
+              </a:rPr>
               <a:t>综合结论：一笔“高赔率、高不确定”的 AI 平台期权</a:t>
             </a:r>
           </a:p>
@@ -9060,7 +9525,7 @@
 </p:sld>
 </file>
 
-<file path=ppt/slides/slide18.xml><?xml version="1.0" encoding="utf-8"?>
+<file path=ppt/slides/slide19.xml><?xml version="1.0" encoding="utf-8"?>
 <p:sld xmlns:a="http://schemas.openxmlformats.org/drawingml/2006/main" xmlns:p="http://schemas.openxmlformats.org/presentationml/2006/main" xmlns:r="http://schemas.openxmlformats.org/officeDocument/2006/relationships">
   <p:cSld>
     <p:spTree>

</xml_diff>